<commit_message>
Team affiliation: M bank logo and roles on title/closing slides, description and video intro
</commit_message>
<xml_diff>
--- a/submission/Kervan_TL_pitch_deck.pptx
+++ b/submission/Kervan_TL_pitch_deck.pptx
@@ -6930,7 +6930,7 @@
             </a:pPr>
             <a:r>
               <a:rPr sz="1300" b="0"/>
-              <a:t>Team name: TL</a:t>
+              <a:t>Team name: TL  ·  Taivanbat Bayarsaikhan (leader), Lkhagvadorj Munkhdalai</a:t>
             </a:r>
             <a:endParaRPr sz="1800">
               <a:latin typeface="Google Sans Flex Medium"/>
@@ -6951,13 +6951,13 @@
               <a:buSzPts val="1800"/>
             </a:pPr>
             <a:r>
-              <a:rPr lang="en-GB" sz="1300" b="0">
+              <a:rPr lang="en-GB" sz="1200" b="0">
                 <a:latin typeface="Google Sans Flex"/>
                 <a:ea typeface="Google Sans Flex"/>
                 <a:cs typeface="Google Sans Flex"/>
                 <a:sym typeface="Google Sans Flex"/>
               </a:rPr>
-              <a:t>Team leader name: Taivanbat.B   ·   Member: Lkhagvadorj.M</a:t>
+              <a:t>AI Engineers &amp; Data Scientists at M bank, Mongolia's first neobank (fully digital, licensed 2022)</a:t>
             </a:r>
             <a:endParaRPr sz="1800">
               <a:latin typeface="Google Sans Flex"/>
@@ -7095,6 +7095,30 @@
           <a:ln>
             <a:noFill/>
           </a:ln>
+        </p:spPr>
+      </p:pic>
+      <p:pic>
+        <p:nvPicPr>
+          <p:cNvPr id="57" name="Picture 56" descr="mbank_logo.png"/>
+          <p:cNvPicPr>
+            <a:picLocks noChangeAspect="1"/>
+          </p:cNvPicPr>
+          <p:nvPr/>
+        </p:nvPicPr>
+        <p:blipFill>
+          <a:blip r:embed="rId5"/>
+          <a:stretch>
+            <a:fillRect/>
+          </a:stretch>
+        </p:blipFill>
+        <p:spPr>
+          <a:xfrm>
+            <a:off x="7360920" y="4370832"/>
+            <a:ext cx="1463040" cy="614477"/>
+          </a:xfrm>
+          <a:prstGeom prst="rect">
+            <a:avLst/>
+          </a:prstGeom>
         </p:spPr>
       </p:pic>
     </p:spTree>
@@ -9305,17 +9329,60 @@
               </a:spcAft>
             </a:pPr>
             <a:r>
+              <a:rPr sz="1300" b="0">
+                <a:solidFill>
+                  <a:srgbClr val="6B7280"/>
+                </a:solidFill>
+                <a:latin typeface="Arial"/>
+              </a:rPr>
+              <a:t>Team TL · Taivanbat Bayarsaikhan · Lkhagvadorj Munkhdalai</a:t>
+            </a:r>
+          </a:p>
+          <a:p>
+            <a:pPr algn="l">
+              <a:lnSpc>
+                <a:spcPct val="110000"/>
+              </a:lnSpc>
+              <a:spcAft>
+                <a:spcPts val="400"/>
+              </a:spcAft>
+            </a:pPr>
+            <a:r>
               <a:rPr sz="1200" b="0">
                 <a:solidFill>
                   <a:srgbClr val="6B7280"/>
                 </a:solidFill>
                 <a:latin typeface="Arial"/>
               </a:rPr>
-              <a:t>Team TL · Taivanbat.B · Lkhagvadorj.M</a:t>
+              <a:t>AI Engineers &amp; Data Scientists at M bank, Mongolia's first neobank</a:t>
             </a:r>
           </a:p>
         </p:txBody>
       </p:sp>
+      <p:pic>
+        <p:nvPicPr>
+          <p:cNvPr id="168" name="Picture 167" descr="mbank_logo.png"/>
+          <p:cNvPicPr>
+            <a:picLocks noChangeAspect="1"/>
+          </p:cNvPicPr>
+          <p:nvPr/>
+        </p:nvPicPr>
+        <p:blipFill>
+          <a:blip r:embed="rId5"/>
+          <a:stretch>
+            <a:fillRect/>
+          </a:stretch>
+        </p:blipFill>
+        <p:spPr>
+          <a:xfrm>
+            <a:off x="7040880" y="868680"/>
+            <a:ext cx="1737360" cy="729691"/>
+          </a:xfrm>
+          <a:prstGeom prst="rect">
+            <a:avLst/>
+          </a:prstGeom>
+        </p:spPr>
+      </p:pic>
     </p:spTree>
   </p:cSld>
   <p:clrMapOvr>

</xml_diff>

<commit_message>
Deployed to Cloud Run (ai-builder-cup-2026-mn, asia-northeast1): URL on the deck and README; tolerant deploy.ps1
</commit_message>
<xml_diff>
--- a/submission/Kervan_TL_pitch_deck.pptx
+++ b/submission/Kervan_TL_pitch_deck.pptx
@@ -9094,7 +9094,7 @@
                 </a:solidFill>
                 <a:latin typeface="Arial"/>
               </a:rPr>
-              <a:t>(demo video link)</a:t>
+              <a:t>(demo video link — fill in after upload)</a:t>
             </a:r>
           </a:p>
           <a:p>
@@ -9132,7 +9132,7 @@
                 </a:solidFill>
                 <a:latin typeface="Arial"/>
               </a:rPr>
-              <a:t>(Cloud Run URL)</a:t>
+              <a:t>https://kervan-credit-passport-793182253173.asia-northeast1.run.app</a:t>
             </a:r>
           </a:p>
         </p:txBody>

</xml_diff>